<commit_message>
Update My Azure Extension to ver 0.4.0
</commit_message>
<xml_diff>
--- a/My Azure Extension.pptx
+++ b/My Azure Extension.pptx
@@ -10,7 +10,8 @@
     <p:sldId id="257" r:id="rId4"/>
     <p:sldId id="260" r:id="rId5"/>
     <p:sldId id="259" r:id="rId6"/>
-    <p:sldId id="261" r:id="rId7"/>
+    <p:sldId id="262" r:id="rId7"/>
+    <p:sldId id="261" r:id="rId8"/>
   </p:sldIdLst>
   <p:sldSz cx="12192000" cy="6858000"/>
   <p:notesSz cx="6858000" cy="9144000"/>
@@ -264,7 +265,7 @@
           <a:p>
             <a:fld id="{DD956615-4E69-4601-879E-C9C61DEA03B6}" type="datetimeFigureOut">
               <a:rPr lang="en-US" smtClean="0"/>
-              <a:t>8/10/2023</a:t>
+              <a:t>7/9/2026</a:t>
             </a:fld>
             <a:endParaRPr lang="en-US"/>
           </a:p>
@@ -462,7 +463,7 @@
           <a:p>
             <a:fld id="{DD956615-4E69-4601-879E-C9C61DEA03B6}" type="datetimeFigureOut">
               <a:rPr lang="en-US" smtClean="0"/>
-              <a:t>8/10/2023</a:t>
+              <a:t>7/9/2026</a:t>
             </a:fld>
             <a:endParaRPr lang="en-US"/>
           </a:p>
@@ -670,7 +671,7 @@
           <a:p>
             <a:fld id="{DD956615-4E69-4601-879E-C9C61DEA03B6}" type="datetimeFigureOut">
               <a:rPr lang="en-US" smtClean="0"/>
-              <a:t>8/10/2023</a:t>
+              <a:t>7/9/2026</a:t>
             </a:fld>
             <a:endParaRPr lang="en-US"/>
           </a:p>
@@ -868,7 +869,7 @@
           <a:p>
             <a:fld id="{DD956615-4E69-4601-879E-C9C61DEA03B6}" type="datetimeFigureOut">
               <a:rPr lang="en-US" smtClean="0"/>
-              <a:t>8/10/2023</a:t>
+              <a:t>7/9/2026</a:t>
             </a:fld>
             <a:endParaRPr lang="en-US"/>
           </a:p>
@@ -1143,7 +1144,7 @@
           <a:p>
             <a:fld id="{DD956615-4E69-4601-879E-C9C61DEA03B6}" type="datetimeFigureOut">
               <a:rPr lang="en-US" smtClean="0"/>
-              <a:t>8/10/2023</a:t>
+              <a:t>7/9/2026</a:t>
             </a:fld>
             <a:endParaRPr lang="en-US"/>
           </a:p>
@@ -1408,7 +1409,7 @@
           <a:p>
             <a:fld id="{DD956615-4E69-4601-879E-C9C61DEA03B6}" type="datetimeFigureOut">
               <a:rPr lang="en-US" smtClean="0"/>
-              <a:t>8/10/2023</a:t>
+              <a:t>7/9/2026</a:t>
             </a:fld>
             <a:endParaRPr lang="en-US"/>
           </a:p>
@@ -1820,7 +1821,7 @@
           <a:p>
             <a:fld id="{DD956615-4E69-4601-879E-C9C61DEA03B6}" type="datetimeFigureOut">
               <a:rPr lang="en-US" smtClean="0"/>
-              <a:t>8/10/2023</a:t>
+              <a:t>7/9/2026</a:t>
             </a:fld>
             <a:endParaRPr lang="en-US"/>
           </a:p>
@@ -1961,7 +1962,7 @@
           <a:p>
             <a:fld id="{DD956615-4E69-4601-879E-C9C61DEA03B6}" type="datetimeFigureOut">
               <a:rPr lang="en-US" smtClean="0"/>
-              <a:t>8/10/2023</a:t>
+              <a:t>7/9/2026</a:t>
             </a:fld>
             <a:endParaRPr lang="en-US"/>
           </a:p>
@@ -2074,7 +2075,7 @@
           <a:p>
             <a:fld id="{DD956615-4E69-4601-879E-C9C61DEA03B6}" type="datetimeFigureOut">
               <a:rPr lang="en-US" smtClean="0"/>
-              <a:t>8/10/2023</a:t>
+              <a:t>7/9/2026</a:t>
             </a:fld>
             <a:endParaRPr lang="en-US"/>
           </a:p>
@@ -2385,7 +2386,7 @@
           <a:p>
             <a:fld id="{DD956615-4E69-4601-879E-C9C61DEA03B6}" type="datetimeFigureOut">
               <a:rPr lang="en-US" smtClean="0"/>
-              <a:t>8/10/2023</a:t>
+              <a:t>7/9/2026</a:t>
             </a:fld>
             <a:endParaRPr lang="en-US"/>
           </a:p>
@@ -2673,7 +2674,7 @@
           <a:p>
             <a:fld id="{DD956615-4E69-4601-879E-C9C61DEA03B6}" type="datetimeFigureOut">
               <a:rPr lang="en-US" smtClean="0"/>
-              <a:t>8/10/2023</a:t>
+              <a:t>7/9/2026</a:t>
             </a:fld>
             <a:endParaRPr lang="en-US"/>
           </a:p>
@@ -2914,7 +2915,7 @@
           <a:p>
             <a:fld id="{DD956615-4E69-4601-879E-C9C61DEA03B6}" type="datetimeFigureOut">
               <a:rPr lang="en-US" smtClean="0"/>
-              <a:t>8/10/2023</a:t>
+              <a:t>7/9/2026</a:t>
             </a:fld>
             <a:endParaRPr lang="en-US"/>
           </a:p>
@@ -4354,6 +4355,256 @@
           <p:cNvPr id="5" name="Picture 4">
             <a:extLst>
               <a:ext uri="{FF2B5EF4-FFF2-40B4-BE49-F238E27FC236}">
+                <a16:creationId xmlns:a16="http://schemas.microsoft.com/office/drawing/2014/main" id="{EFD62122-1E9B-A461-F9F4-1A9E7DFC6C06}"/>
+              </a:ext>
+            </a:extLst>
+          </p:cNvPr>
+          <p:cNvPicPr>
+            <a:picLocks noChangeAspect="1"/>
+          </p:cNvPicPr>
+          <p:nvPr/>
+        </p:nvPicPr>
+        <p:blipFill>
+          <a:blip r:embed="rId2"/>
+          <a:stretch>
+            <a:fillRect/>
+          </a:stretch>
+        </p:blipFill>
+        <p:spPr>
+          <a:xfrm>
+            <a:off x="3600101" y="585390"/>
+            <a:ext cx="4991797" cy="5687219"/>
+          </a:xfrm>
+          <a:prstGeom prst="rect">
+            <a:avLst/>
+          </a:prstGeom>
+        </p:spPr>
+      </p:pic>
+      <p:sp>
+        <p:nvSpPr>
+          <p:cNvPr id="7" name="Rectangle 6">
+            <a:extLst>
+              <a:ext uri="{FF2B5EF4-FFF2-40B4-BE49-F238E27FC236}">
+                <a16:creationId xmlns:a16="http://schemas.microsoft.com/office/drawing/2014/main" id="{7B0DC751-7AA6-9733-67FD-907CA822C892}"/>
+              </a:ext>
+            </a:extLst>
+          </p:cNvPr>
+          <p:cNvSpPr/>
+          <p:nvPr/>
+        </p:nvSpPr>
+        <p:spPr>
+          <a:xfrm>
+            <a:off x="3600100" y="3965027"/>
+            <a:ext cx="4834451" cy="1931275"/>
+          </a:xfrm>
+          <a:prstGeom prst="rect">
+            <a:avLst/>
+          </a:prstGeom>
+          <a:noFill/>
+          <a:ln w="50800">
+            <a:solidFill>
+              <a:srgbClr val="FF0000"/>
+            </a:solidFill>
+          </a:ln>
+        </p:spPr>
+        <p:style>
+          <a:lnRef idx="2">
+            <a:schemeClr val="accent1">
+              <a:shade val="50000"/>
+            </a:schemeClr>
+          </a:lnRef>
+          <a:fillRef idx="1">
+            <a:schemeClr val="accent1"/>
+          </a:fillRef>
+          <a:effectRef idx="0">
+            <a:schemeClr val="accent1"/>
+          </a:effectRef>
+          <a:fontRef idx="minor">
+            <a:schemeClr val="lt1"/>
+          </a:fontRef>
+        </p:style>
+        <p:txBody>
+          <a:bodyPr rtlCol="0" anchor="ctr"/>
+          <a:lstStyle/>
+          <a:p>
+            <a:pPr algn="ctr"/>
+            <a:endParaRPr lang="en-US"/>
+          </a:p>
+        </p:txBody>
+      </p:sp>
+      <p:sp>
+        <p:nvSpPr>
+          <p:cNvPr id="8" name="Rectangle 7">
+            <a:extLst>
+              <a:ext uri="{FF2B5EF4-FFF2-40B4-BE49-F238E27FC236}">
+                <a16:creationId xmlns:a16="http://schemas.microsoft.com/office/drawing/2014/main" id="{05AF9EDF-1D56-BC23-4AF3-995F1A2EDF11}"/>
+              </a:ext>
+            </a:extLst>
+          </p:cNvPr>
+          <p:cNvSpPr/>
+          <p:nvPr/>
+        </p:nvSpPr>
+        <p:spPr>
+          <a:xfrm>
+            <a:off x="4382814" y="4903076"/>
+            <a:ext cx="2151993" cy="134007"/>
+          </a:xfrm>
+          <a:prstGeom prst="rect">
+            <a:avLst/>
+          </a:prstGeom>
+        </p:spPr>
+        <p:style>
+          <a:lnRef idx="2">
+            <a:schemeClr val="dk1">
+              <a:shade val="15000"/>
+            </a:schemeClr>
+          </a:lnRef>
+          <a:fillRef idx="1">
+            <a:schemeClr val="dk1"/>
+          </a:fillRef>
+          <a:effectRef idx="0">
+            <a:schemeClr val="dk1"/>
+          </a:effectRef>
+          <a:fontRef idx="minor">
+            <a:schemeClr val="lt1"/>
+          </a:fontRef>
+        </p:style>
+        <p:txBody>
+          <a:bodyPr rtlCol="0" anchor="ctr"/>
+          <a:lstStyle/>
+          <a:p>
+            <a:pPr algn="ctr"/>
+            <a:endParaRPr lang="en-US"/>
+          </a:p>
+        </p:txBody>
+      </p:sp>
+      <p:sp>
+        <p:nvSpPr>
+          <p:cNvPr id="10" name="Rectangle 9">
+            <a:extLst>
+              <a:ext uri="{FF2B5EF4-FFF2-40B4-BE49-F238E27FC236}">
+                <a16:creationId xmlns:a16="http://schemas.microsoft.com/office/drawing/2014/main" id="{A123CEA6-43F6-5255-DF6A-E6C9F646E0EF}"/>
+              </a:ext>
+            </a:extLst>
+          </p:cNvPr>
+          <p:cNvSpPr/>
+          <p:nvPr/>
+        </p:nvSpPr>
+        <p:spPr>
+          <a:xfrm>
+            <a:off x="4382814" y="5256485"/>
+            <a:ext cx="2151993" cy="134007"/>
+          </a:xfrm>
+          <a:prstGeom prst="rect">
+            <a:avLst/>
+          </a:prstGeom>
+        </p:spPr>
+        <p:style>
+          <a:lnRef idx="2">
+            <a:schemeClr val="dk1">
+              <a:shade val="15000"/>
+            </a:schemeClr>
+          </a:lnRef>
+          <a:fillRef idx="1">
+            <a:schemeClr val="dk1"/>
+          </a:fillRef>
+          <a:effectRef idx="0">
+            <a:schemeClr val="dk1"/>
+          </a:effectRef>
+          <a:fontRef idx="minor">
+            <a:schemeClr val="lt1"/>
+          </a:fontRef>
+        </p:style>
+        <p:txBody>
+          <a:bodyPr rtlCol="0" anchor="ctr"/>
+          <a:lstStyle/>
+          <a:p>
+            <a:pPr algn="ctr"/>
+            <a:endParaRPr lang="en-US"/>
+          </a:p>
+        </p:txBody>
+      </p:sp>
+      <p:sp>
+        <p:nvSpPr>
+          <p:cNvPr id="12" name="Rectangle 11">
+            <a:extLst>
+              <a:ext uri="{FF2B5EF4-FFF2-40B4-BE49-F238E27FC236}">
+                <a16:creationId xmlns:a16="http://schemas.microsoft.com/office/drawing/2014/main" id="{640C58B3-5677-F8F1-097F-0A5035F87DD9}"/>
+              </a:ext>
+            </a:extLst>
+          </p:cNvPr>
+          <p:cNvSpPr/>
+          <p:nvPr/>
+        </p:nvSpPr>
+        <p:spPr>
+          <a:xfrm>
+            <a:off x="4382813" y="4568057"/>
+            <a:ext cx="2151993" cy="134007"/>
+          </a:xfrm>
+          <a:prstGeom prst="rect">
+            <a:avLst/>
+          </a:prstGeom>
+        </p:spPr>
+        <p:style>
+          <a:lnRef idx="2">
+            <a:schemeClr val="dk1">
+              <a:shade val="15000"/>
+            </a:schemeClr>
+          </a:lnRef>
+          <a:fillRef idx="1">
+            <a:schemeClr val="dk1"/>
+          </a:fillRef>
+          <a:effectRef idx="0">
+            <a:schemeClr val="dk1"/>
+          </a:effectRef>
+          <a:fontRef idx="minor">
+            <a:schemeClr val="lt1"/>
+          </a:fontRef>
+        </p:style>
+        <p:txBody>
+          <a:bodyPr rtlCol="0" anchor="ctr"/>
+          <a:lstStyle/>
+          <a:p>
+            <a:pPr algn="ctr"/>
+            <a:endParaRPr lang="en-US"/>
+          </a:p>
+        </p:txBody>
+      </p:sp>
+    </p:spTree>
+    <p:extLst>
+      <p:ext uri="{BB962C8B-B14F-4D97-AF65-F5344CB8AC3E}">
+        <p14:creationId xmlns:p14="http://schemas.microsoft.com/office/powerpoint/2010/main" val="4233353208"/>
+      </p:ext>
+    </p:extLst>
+  </p:cSld>
+  <p:clrMapOvr>
+    <a:masterClrMapping/>
+  </p:clrMapOvr>
+</p:sld>
+</file>
+
+<file path=ppt/slides/slide7.xml><?xml version="1.0" encoding="utf-8"?>
+<p:sld xmlns:a="http://schemas.openxmlformats.org/drawingml/2006/main" xmlns:r="http://schemas.openxmlformats.org/officeDocument/2006/relationships" xmlns:p="http://schemas.openxmlformats.org/presentationml/2006/main">
+  <p:cSld>
+    <p:spTree>
+      <p:nvGrpSpPr>
+        <p:cNvPr id="1" name=""/>
+        <p:cNvGrpSpPr/>
+        <p:nvPr/>
+      </p:nvGrpSpPr>
+      <p:grpSpPr>
+        <a:xfrm>
+          <a:off x="0" y="0"/>
+          <a:ext cx="0" cy="0"/>
+          <a:chOff x="0" y="0"/>
+          <a:chExt cx="0" cy="0"/>
+        </a:xfrm>
+      </p:grpSpPr>
+      <p:pic>
+        <p:nvPicPr>
+          <p:cNvPr id="5" name="Picture 4">
+            <a:extLst>
+              <a:ext uri="{FF2B5EF4-FFF2-40B4-BE49-F238E27FC236}">
                 <a16:creationId xmlns:a16="http://schemas.microsoft.com/office/drawing/2014/main" id="{A8A65ECA-FC08-7DD1-42A4-B24B60D7F337}"/>
               </a:ext>
             </a:extLst>

</xml_diff>